<commit_message>
Allow all materials for Chlamydia trachomatis #213
</commit_message>
<xml_diff>
--- a/ig-images.pptx
+++ b/ig-images.pptx
@@ -34293,7 +34293,7 @@
                 <a:latin typeface="Verdana" panose="020B0604030504040204" pitchFamily="34" charset="0"/>
                 <a:ea typeface="Verdana" panose="020B0604030504040204" pitchFamily="34" charset="0"/>
               </a:rPr>
-              <a:t>CH ELM Results Geni </a:t>
+              <a:t>CH ELM Results Complete </a:t>
             </a:r>
             <a:r>
               <a:rPr lang="sv-SE" sz="1050" b="1" dirty="0" err="1">
@@ -34613,7 +34613,7 @@
                 <a:latin typeface="Verdana" panose="020B0604030504040204" pitchFamily="34" charset="0"/>
                 <a:ea typeface="Verdana" panose="020B0604030504040204" pitchFamily="34" charset="0"/>
               </a:rPr>
-              <a:t>geni</a:t>
+              <a:t>complete</a:t>
             </a:r>
             <a:r>
               <a:rPr lang="en-US" sz="1050" dirty="0">

</xml_diff>